<commit_message>
Chuẩn hóa font theme của 8 deck về Cambria/Calibri
Theme mặc định do PptxGenJS sinh ra vẫn khai Calibri Light và các font
Nhật/Hàn/Trung, không khớp hệ thống thiết kế và không dùng cho tiếng Việt.
Sau khi sửa, kiểm định pptx_delivery_check của ppt-master cho kết quả
passed, 0 lỗi 0 cảnh báo trên cả 8 tệp; slide mới tạo trong PowerPoint
sẽ kế thừa đúng Cambria cho tiêu đề và Calibri cho nội dung.
</commit_message>
<xml_diff>
--- a/practice/bai-1-the-thuc.pptx
+++ b/practice/bai-1-the-thuc.pptx
@@ -8614,108 +8614,14 @@
     </a:clrScheme>
     <a:fontScheme name="Office">
       <a:majorFont>
-        <a:latin typeface="Calibri Light" panose="020F0302020204030204"/>
-        <a:ea typeface=""/>
-        <a:cs typeface=""/>
-        <a:font script="Jpan" typeface="游ゴシック Light"/>
-        <a:font script="Hang" typeface="맑은 고딕"/>
-        <a:font script="Hans" typeface="等线 Light"/>
-        <a:font script="Hant" typeface="新細明體"/>
-        <a:font script="Arab" typeface="Times New Roman"/>
-        <a:font script="Hebr" typeface="Times New Roman"/>
-        <a:font script="Thai" typeface="Angsana New"/>
-        <a:font script="Ethi" typeface="Nyala"/>
-        <a:font script="Beng" typeface="Vrinda"/>
-        <a:font script="Gujr" typeface="Shruti"/>
-        <a:font script="Khmr" typeface="MoolBoran"/>
-        <a:font script="Knda" typeface="Tunga"/>
-        <a:font script="Guru" typeface="Raavi"/>
-        <a:font script="Cans" typeface="Euphemia"/>
-        <a:font script="Cher" typeface="Plantagenet Cherokee"/>
-        <a:font script="Yiii" typeface="Microsoft Yi Baiti"/>
-        <a:font script="Tibt" typeface="Microsoft Himalaya"/>
-        <a:font script="Thaa" typeface="MV Boli"/>
-        <a:font script="Deva" typeface="Mangal"/>
-        <a:font script="Telu" typeface="Gautami"/>
-        <a:font script="Taml" typeface="Latha"/>
-        <a:font script="Syrc" typeface="Estrangelo Edessa"/>
-        <a:font script="Orya" typeface="Kalinga"/>
-        <a:font script="Mlym" typeface="Kartika"/>
-        <a:font script="Laoo" typeface="DokChampa"/>
-        <a:font script="Sinh" typeface="Iskoola Pota"/>
-        <a:font script="Mong" typeface="Mongolian Baiti"/>
-        <a:font script="Viet" typeface="Times New Roman"/>
-        <a:font script="Uigh" typeface="Microsoft Uighur"/>
-        <a:font script="Geor" typeface="Sylfaen"/>
-        <a:font script="Armn" typeface="Arial"/>
-        <a:font script="Bugi" typeface="Leelawadee UI"/>
-        <a:font script="Bopo" typeface="Microsoft JhengHei"/>
-        <a:font script="Java" typeface="Javanese Text"/>
-        <a:font script="Lisu" typeface="Segoe UI"/>
-        <a:font script="Mymr" typeface="Myanmar Text"/>
-        <a:font script="Nkoo" typeface="Ebrima"/>
-        <a:font script="Olck" typeface="Nirmala UI"/>
-        <a:font script="Osma" typeface="Ebrima"/>
-        <a:font script="Phag" typeface="Phagspa"/>
-        <a:font script="Syrn" typeface="Estrangelo Edessa"/>
-        <a:font script="Syrj" typeface="Estrangelo Edessa"/>
-        <a:font script="Syre" typeface="Estrangelo Edessa"/>
-        <a:font script="Sora" typeface="Nirmala UI"/>
-        <a:font script="Tale" typeface="Microsoft Tai Le"/>
-        <a:font script="Talu" typeface="Microsoft New Tai Lue"/>
-        <a:font script="Tfng" typeface="Ebrima"/>
+        <a:latin typeface="Cambria" panose="020F0302020204030204"/>
+        <a:ea typeface="Cambria"/>
+        <a:cs typeface="Cambria"/>
       </a:majorFont>
       <a:minorFont>
         <a:latin typeface="Calibri" panose="020F0502020204030204"/>
-        <a:ea typeface=""/>
-        <a:cs typeface=""/>
-        <a:font script="Jpan" typeface="游ゴシック"/>
-        <a:font script="Hang" typeface="맑은 고딕"/>
-        <a:font script="Hans" typeface="等线"/>
-        <a:font script="Hant" typeface="新細明體"/>
-        <a:font script="Arab" typeface="Arial"/>
-        <a:font script="Hebr" typeface="Arial"/>
-        <a:font script="Thai" typeface="Cordia New"/>
-        <a:font script="Ethi" typeface="Nyala"/>
-        <a:font script="Beng" typeface="Vrinda"/>
-        <a:font script="Gujr" typeface="Shruti"/>
-        <a:font script="Khmr" typeface="DaunPenh"/>
-        <a:font script="Knda" typeface="Tunga"/>
-        <a:font script="Guru" typeface="Raavi"/>
-        <a:font script="Cans" typeface="Euphemia"/>
-        <a:font script="Cher" typeface="Plantagenet Cherokee"/>
-        <a:font script="Yiii" typeface="Microsoft Yi Baiti"/>
-        <a:font script="Tibt" typeface="Microsoft Himalaya"/>
-        <a:font script="Thaa" typeface="MV Boli"/>
-        <a:font script="Deva" typeface="Mangal"/>
-        <a:font script="Telu" typeface="Gautami"/>
-        <a:font script="Taml" typeface="Latha"/>
-        <a:font script="Syrc" typeface="Estrangelo Edessa"/>
-        <a:font script="Orya" typeface="Kalinga"/>
-        <a:font script="Mlym" typeface="Kartika"/>
-        <a:font script="Laoo" typeface="DokChampa"/>
-        <a:font script="Sinh" typeface="Iskoola Pota"/>
-        <a:font script="Mong" typeface="Mongolian Baiti"/>
-        <a:font script="Viet" typeface="Arial"/>
-        <a:font script="Uigh" typeface="Microsoft Uighur"/>
-        <a:font script="Geor" typeface="Sylfaen"/>
-        <a:font script="Armn" typeface="Arial"/>
-        <a:font script="Bugi" typeface="Leelawadee UI"/>
-        <a:font script="Bopo" typeface="Microsoft JhengHei"/>
-        <a:font script="Java" typeface="Javanese Text"/>
-        <a:font script="Lisu" typeface="Segoe UI"/>
-        <a:font script="Mymr" typeface="Myanmar Text"/>
-        <a:font script="Nkoo" typeface="Ebrima"/>
-        <a:font script="Olck" typeface="Nirmala UI"/>
-        <a:font script="Osma" typeface="Ebrima"/>
-        <a:font script="Phag" typeface="Phagspa"/>
-        <a:font script="Syrn" typeface="Estrangelo Edessa"/>
-        <a:font script="Syrj" typeface="Estrangelo Edessa"/>
-        <a:font script="Syre" typeface="Estrangelo Edessa"/>
-        <a:font script="Sora" typeface="Nirmala UI"/>
-        <a:font script="Tale" typeface="Microsoft Tai Le"/>
-        <a:font script="Talu" typeface="Microsoft New Tai Lue"/>
-        <a:font script="Tfng" typeface="Ebrima"/>
+        <a:ea typeface="Calibri"/>
+        <a:cs typeface="Calibri"/>
       </a:minorFont>
     </a:fontScheme>
     <a:fmtScheme name="Office">

</xml_diff>

<commit_message>
Ba video thực hành: đổi mã học phần EC1103 -> EC6000TX
Áp dụng cùng cách đã làm cho Chương 5: footer mọi trang nội dung của
ba bộ slide thực hành (Bài 1/2/3) đổi từ EC1103 sang EC6000TX, vì cả
ba video này giờ cũng thuộc gói học liệu hệ từ xa Chương 5. Trang bìa
(META_TH) không có mã học phần nên không đổi gì.

Nguồn sinh (design.js, build_ch5_practice.js, apply_upgrade.py) đã
thêm tham số mã học phần từ trước, mặc định vẫn EC1103 cho c1-c4 —
lần này chỉ truyền EC6000TX cho th1/th2/th3. Ảnh JPEG trong trình xem
(assets/slides/th1,2,3) đã dựng lại khớp theo. Nâng PHIEN_BAN vì đổi
nhiều tệp trong assets/.
</commit_message>
<xml_diff>
--- a/practice/bai-1-the-thuc.pptx
+++ b/practice/bai-1-the-thuc.pptx
@@ -2273,7 +2273,7 @@
                 <a:ea typeface="Calibri" pitchFamily="34" charset="-122"/>
                 <a:cs typeface="Calibri" pitchFamily="34" charset="-120"/>
               </a:rPr>
-              <a:t>Je m'appelle Huong  •  GV. Đỗ Thùy Hương  •  EC1103</a:t>
+              <a:t>Je m'appelle Huong  •  GV. Đỗ Thùy Hương  •  EC6000TX</a:t>
             </a:r>
             <a:endParaRPr lang="en-US" sz="900" dirty="0"/>
           </a:p>
@@ -2809,7 +2809,7 @@
                 <a:ea typeface="Calibri" pitchFamily="34" charset="-122"/>
                 <a:cs typeface="Calibri" pitchFamily="34" charset="-120"/>
               </a:rPr>
-              <a:t>Je m'appelle Huong  •  GV. Đỗ Thùy Hương  •  EC1103</a:t>
+              <a:t>Je m'appelle Huong  •  GV. Đỗ Thùy Hương  •  EC6000TX</a:t>
             </a:r>
             <a:endParaRPr lang="en-US" sz="900" dirty="0"/>
           </a:p>
@@ -3345,7 +3345,7 @@
                 <a:ea typeface="Calibri" pitchFamily="34" charset="-122"/>
                 <a:cs typeface="Calibri" pitchFamily="34" charset="-120"/>
               </a:rPr>
-              <a:t>Je m'appelle Huong  •  GV. Đỗ Thùy Hương  •  EC1103</a:t>
+              <a:t>Je m'appelle Huong  •  GV. Đỗ Thùy Hương  •  EC6000TX</a:t>
             </a:r>
             <a:endParaRPr lang="en-US" sz="900" dirty="0"/>
           </a:p>
@@ -3968,7 +3968,7 @@
                 <a:ea typeface="Calibri" pitchFamily="34" charset="-122"/>
                 <a:cs typeface="Calibri" pitchFamily="34" charset="-120"/>
               </a:rPr>
-              <a:t>Je m'appelle Huong  •  GV. Đỗ Thùy Hương  •  EC1103</a:t>
+              <a:t>Je m'appelle Huong  •  GV. Đỗ Thùy Hương  •  EC6000TX</a:t>
             </a:r>
             <a:endParaRPr lang="en-US" sz="900" dirty="0"/>
           </a:p>
@@ -4475,7 +4475,7 @@
                 <a:ea typeface="Calibri" pitchFamily="34" charset="-122"/>
                 <a:cs typeface="Calibri" pitchFamily="34" charset="-120"/>
               </a:rPr>
-              <a:t>Je m'appelle Huong  •  GV. Đỗ Thùy Hương  •  EC1103</a:t>
+              <a:t>Je m'appelle Huong  •  GV. Đỗ Thùy Hương  •  EC6000TX</a:t>
             </a:r>
             <a:endParaRPr lang="en-US" sz="900" dirty="0"/>
           </a:p>
@@ -5285,7 +5285,7 @@
                 <a:ea typeface="Calibri" pitchFamily="34" charset="-122"/>
                 <a:cs typeface="Calibri" pitchFamily="34" charset="-120"/>
               </a:rPr>
-              <a:t>Je m'appelle Huong  •  GV. Đỗ Thùy Hương  •  EC1103</a:t>
+              <a:t>Je m'appelle Huong  •  GV. Đỗ Thùy Hương  •  EC6000TX</a:t>
             </a:r>
             <a:endParaRPr lang="en-US" sz="900" dirty="0"/>
           </a:p>
@@ -5908,7 +5908,7 @@
                 <a:ea typeface="Calibri" pitchFamily="34" charset="-122"/>
                 <a:cs typeface="Calibri" pitchFamily="34" charset="-120"/>
               </a:rPr>
-              <a:t>Je m'appelle Huong  •  GV. Đỗ Thùy Hương  •  EC1103</a:t>
+              <a:t>Je m'appelle Huong  •  GV. Đỗ Thùy Hương  •  EC6000TX</a:t>
             </a:r>
             <a:endParaRPr lang="en-US" sz="900" dirty="0"/>
           </a:p>
@@ -6207,7 +6207,7 @@
                 <a:ea typeface="Calibri" pitchFamily="34" charset="-122"/>
                 <a:cs typeface="Calibri" pitchFamily="34" charset="-120"/>
               </a:rPr>
-              <a:t>Je m'appelle Huong  •  GV. Đỗ Thùy Hương  •  EC1103</a:t>
+              <a:t>Je m'appelle Huong  •  GV. Đỗ Thùy Hương  •  EC6000TX</a:t>
             </a:r>
             <a:endParaRPr lang="en-US" sz="900" dirty="0"/>
           </a:p>
@@ -6830,7 +6830,7 @@
                 <a:ea typeface="Calibri" pitchFamily="34" charset="-122"/>
                 <a:cs typeface="Calibri" pitchFamily="34" charset="-120"/>
               </a:rPr>
-              <a:t>Je m'appelle Huong  •  GV. Đỗ Thùy Hương  •  EC1103</a:t>
+              <a:t>Je m'appelle Huong  •  GV. Đỗ Thùy Hương  •  EC6000TX</a:t>
             </a:r>
             <a:endParaRPr lang="en-US" sz="900" dirty="0"/>
           </a:p>
@@ -7921,7 +7921,7 @@
                 <a:ea typeface="Calibri" pitchFamily="34" charset="-122"/>
                 <a:cs typeface="Calibri" pitchFamily="34" charset="-120"/>
               </a:rPr>
-              <a:t>Je m'appelle Huong  •  GV. Đỗ Thùy Hương  •  EC1103</a:t>
+              <a:t>Je m'appelle Huong  •  GV. Đỗ Thùy Hương  •  EC6000TX</a:t>
             </a:r>
             <a:endParaRPr lang="en-US" sz="900" dirty="0"/>
           </a:p>

</xml_diff>